<commit_message>
sd-02-024: state the concurrency behind 500 req/s; ULID order holds per millisecond
Co-Authored-By: Claude Opus 5.5 <noreply@anthropic.com>
Claude-Session: https://claude.ai/code/session_01McBLtMnJbTnB94NeVs8a2V
</commit_message>
<xml_diff>
--- a/system-design-101/vi/lessons/sd-02-024/slides/sd-02-024.pptx
+++ b/system-design-101/vi/lessons/sd-02-024/slides/sd-02-024.pptx
@@ -8436,6 +8436,116 @@
               <a:buNone/>
             </a:pPr>
             <a:r>
+              <a:rPr lang="en-US" sz="2550" dirty="0" spc="4" kern="0">
+                <a:solidFill>
+                  <a:srgbClr val="14161C"/>
+                </a:solidFill>
+                <a:latin typeface="Be Vietnam Pro" pitchFamily="34" charset="0"/>
+                <a:ea typeface="Be Vietnam Pro" pitchFamily="34" charset="-122"/>
+                <a:cs typeface="Be Vietnam Pro" pitchFamily="34" charset="-120"/>
+              </a:rPr>
+              <a:t>Nếu</a:t>
+            </a:r>
+            <a:r>
+              <a:rPr lang="en-US" sz="2550" dirty="0" spc="-2" kern="0">
+                <a:solidFill>
+                  <a:srgbClr val="14161C"/>
+                </a:solidFill>
+                <a:latin typeface="Be Vietnam Pro" pitchFamily="34" charset="0"/>
+                <a:ea typeface="Be Vietnam Pro" pitchFamily="34" charset="-122"/>
+                <a:cs typeface="Be Vietnam Pro" pitchFamily="34" charset="-120"/>
+              </a:rPr>
+              <a:t> 50</a:t>
+            </a:r>
+            <a:r>
+              <a:rPr lang="en-US" sz="2550" dirty="0" spc="-21" kern="0">
+                <a:solidFill>
+                  <a:srgbClr val="14161C"/>
+                </a:solidFill>
+                <a:latin typeface="Be Vietnam Pro" pitchFamily="34" charset="0"/>
+                <a:ea typeface="Be Vietnam Pro" pitchFamily="34" charset="-122"/>
+                <a:cs typeface="Be Vietnam Pro" pitchFamily="34" charset="-120"/>
+              </a:rPr>
+              <a:t> yêu</a:t>
+            </a:r>
+            <a:r>
+              <a:rPr lang="en-US" sz="2550" dirty="0" spc="2" kern="0">
+                <a:solidFill>
+                  <a:srgbClr val="14161C"/>
+                </a:solidFill>
+                <a:latin typeface="Be Vietnam Pro" pitchFamily="34" charset="0"/>
+                <a:ea typeface="Be Vietnam Pro" pitchFamily="34" charset="-122"/>
+                <a:cs typeface="Be Vietnam Pro" pitchFamily="34" charset="-120"/>
+              </a:rPr>
+              <a:t> cầu</a:t>
+            </a:r>
+            <a:r>
+              <a:rPr lang="en-US" sz="2550" dirty="0" spc="-7" kern="0">
+                <a:solidFill>
+                  <a:srgbClr val="14161C"/>
+                </a:solidFill>
+                <a:latin typeface="Be Vietnam Pro" pitchFamily="34" charset="0"/>
+                <a:ea typeface="Be Vietnam Pro" pitchFamily="34" charset="-122"/>
+                <a:cs typeface="Be Vietnam Pro" pitchFamily="34" charset="-120"/>
+              </a:rPr>
+              <a:t> chạy</a:t>
+            </a:r>
+            <a:r>
+              <a:rPr lang="en-US" sz="2550" dirty="0" spc="-1" kern="0">
+                <a:solidFill>
+                  <a:srgbClr val="14161C"/>
+                </a:solidFill>
+                <a:latin typeface="Be Vietnam Pro" pitchFamily="34" charset="0"/>
+                <a:ea typeface="Be Vietnam Pro" pitchFamily="34" charset="-122"/>
+                <a:cs typeface="Be Vietnam Pro" pitchFamily="34" charset="-120"/>
+              </a:rPr>
+              <a:t> cùng</a:t>
+            </a:r>
+            <a:r>
+              <a:rPr lang="en-US" sz="2550" dirty="0" spc="-2" kern="0">
+                <a:solidFill>
+                  <a:srgbClr val="14161C"/>
+                </a:solidFill>
+                <a:latin typeface="Be Vietnam Pro" pitchFamily="34" charset="0"/>
+                <a:ea typeface="Be Vietnam Pro" pitchFamily="34" charset="-122"/>
+                <a:cs typeface="Be Vietnam Pro" pitchFamily="34" charset="-120"/>
+              </a:rPr>
+              <a:t> lúc,</a:t>
+            </a:r>
+            <a:r>
+              <a:rPr lang="en-US" sz="2550" dirty="0" spc="0" kern="0">
+                <a:solidFill>
+                  <a:srgbClr val="14161C"/>
+                </a:solidFill>
+                <a:latin typeface="Be Vietnam Pro" pitchFamily="34" charset="0"/>
+                <a:ea typeface="Be Vietnam Pro" pitchFamily="34" charset="-122"/>
+                <a:cs typeface="Be Vietnam Pro" pitchFamily="34" charset="-120"/>
+              </a:rPr>
+              <a:t> mỗi</a:t>
+            </a:r>
+            <a:r>
+              <a:rPr lang="en-US" sz="2550" dirty="0" spc="-20" kern="0">
+                <a:solidFill>
+                  <a:srgbClr val="14161C"/>
+                </a:solidFill>
+                <a:latin typeface="Be Vietnam Pro" pitchFamily="34" charset="0"/>
+                <a:ea typeface="Be Vietnam Pro" pitchFamily="34" charset="-122"/>
+                <a:cs typeface="Be Vietnam Pro" pitchFamily="34" charset="-120"/>
+              </a:rPr>
+              <a:t> yêu</a:t>
+            </a:r>
+            <a:r>
+              <a:rPr lang="en-US" sz="2550" dirty="0" spc="2" kern="0">
+                <a:solidFill>
+                  <a:srgbClr val="14161C"/>
+                </a:solidFill>
+                <a:latin typeface="Be Vietnam Pro" pitchFamily="34" charset="0"/>
+                <a:ea typeface="Be Vietnam Pro" pitchFamily="34" charset="-122"/>
+                <a:cs typeface="Be Vietnam Pro" pitchFamily="34" charset="-120"/>
+              </a:rPr>
+              <a:t> cầu</a:t>
+            </a:r>
+            <a:r>
               <a:rPr lang="en-US" sz="2550" dirty="0" spc="-3" kern="0">
                 <a:solidFill>
                   <a:srgbClr val="14161C"/>
@@ -8444,10 +8554,10 @@
                 <a:ea typeface="Be Vietnam Pro" pitchFamily="34" charset="-122"/>
                 <a:cs typeface="Be Vietnam Pro" pitchFamily="34" charset="-120"/>
               </a:rPr>
-              <a:t>50</a:t>
-            </a:r>
-            <a:r>
-              <a:rPr lang="en-US" sz="2550" dirty="0" spc="-21" kern="0">
+              <a:t> 100</a:t>
+            </a:r>
+            <a:r>
+              <a:rPr lang="en-US" sz="2550" dirty="0" spc="0" kern="0">
                 <a:solidFill>
                   <a:srgbClr val="14161C"/>
                 </a:solidFill>
@@ -8455,10 +8565,10 @@
                 <a:ea typeface="Be Vietnam Pro" pitchFamily="34" charset="-122"/>
                 <a:cs typeface="Be Vietnam Pro" pitchFamily="34" charset="-120"/>
               </a:rPr>
-              <a:t> yêu</a:t>
-            </a:r>
-            <a:r>
-              <a:rPr lang="en-US" sz="2550" dirty="0" spc="3" kern="0">
+              <a:t> mili</a:t>
+            </a:r>
+            <a:r>
+              <a:rPr lang="en-US" sz="2550" dirty="0" spc="-7" kern="0">
                 <a:solidFill>
                   <a:srgbClr val="14161C"/>
                 </a:solidFill>
@@ -8466,10 +8576,10 @@
                 <a:ea typeface="Be Vietnam Pro" pitchFamily="34" charset="-122"/>
                 <a:cs typeface="Be Vietnam Pro" pitchFamily="34" charset="-120"/>
               </a:rPr>
-              <a:t> cầu</a:t>
-            </a:r>
-            <a:r>
-              <a:rPr lang="en-US" sz="2550" dirty="0" spc="-17" kern="0">
+              <a:t> giây;</a:t>
+            </a:r>
+            <a:r>
+              <a:rPr lang="en-US" sz="2550" dirty="0" spc="-1" kern="0">
                 <a:solidFill>
                   <a:srgbClr val="14161C"/>
                 </a:solidFill>
@@ -8477,10 +8587,10 @@
                 <a:ea typeface="Be Vietnam Pro" pitchFamily="34" charset="-122"/>
                 <a:cs typeface="Be Vietnam Pro" pitchFamily="34" charset="-120"/>
               </a:rPr>
-              <a:t> trong</a:t>
-            </a:r>
-            <a:r>
-              <a:rPr lang="en-US" sz="2550" dirty="0" spc="1" kern="0">
+              <a:t> xử lý</a:t>
+            </a:r>
+            <a:r>
+              <a:rPr lang="en-US" sz="2550" dirty="0" spc="0" kern="0">
                 <a:solidFill>
                   <a:srgbClr val="14161C"/>
                 </a:solidFill>
@@ -8488,10 +8598,10 @@
                 <a:ea typeface="Be Vietnam Pro" pitchFamily="34" charset="-122"/>
                 <a:cs typeface="Be Vietnam Pro" pitchFamily="34" charset="-120"/>
               </a:rPr>
-              <a:t> hàng</a:t>
-            </a:r>
-            <a:r>
-              <a:rPr lang="en-US" sz="2550" dirty="0" spc="9" kern="0">
+              <a:t> lần</a:t>
+            </a:r>
+            <a:r>
+              <a:rPr lang="en-US" sz="2550" dirty="0" spc="7" kern="0">
                 <a:solidFill>
                   <a:srgbClr val="14161C"/>
                 </a:solidFill>
@@ -8499,10 +8609,10 @@
                 <a:ea typeface="Be Vietnam Pro" pitchFamily="34" charset="-122"/>
                 <a:cs typeface="Be Vietnam Pro" pitchFamily="34" charset="-120"/>
               </a:rPr>
-              <a:t> đợi,</a:t>
-            </a:r>
-            <a:r>
-              <a:rPr lang="en-US" sz="2550" dirty="0" spc="-3" kern="0">
+              <a:t> lượt</a:t>
+            </a:r>
+            <a:r>
+              <a:rPr lang="en-US" sz="2550" dirty="0" spc="2" kern="0">
                 <a:solidFill>
                   <a:srgbClr val="14161C"/>
                 </a:solidFill>
@@ -8510,7 +8620,7 @@
                 <a:ea typeface="Be Vietnam Pro" pitchFamily="34" charset="-122"/>
                 <a:cs typeface="Be Vietnam Pro" pitchFamily="34" charset="-120"/>
               </a:rPr>
-              <a:t> 100</a:t>
+              <a:t> thì</a:t>
             </a:r>
             <a:r>
               <a:rPr lang="en-US" sz="2550" dirty="0" spc="0" kern="0">
@@ -8521,10 +8631,10 @@
                 <a:ea typeface="Be Vietnam Pro" pitchFamily="34" charset="-122"/>
                 <a:cs typeface="Be Vietnam Pro" pitchFamily="34" charset="-120"/>
               </a:rPr>
-              <a:t> mili</a:t>
-            </a:r>
-            <a:r>
-              <a:rPr lang="en-US" sz="2550" dirty="0" spc="-7" kern="0">
+              <a:t> chỉ</a:t>
+            </a:r>
+            <a:r>
+              <a:rPr lang="en-US" sz="2550" dirty="0" spc="-1" kern="0">
                 <a:solidFill>
                   <a:srgbClr val="14161C"/>
                 </a:solidFill>
@@ -8532,10 +8642,10 @@
                 <a:ea typeface="Be Vietnam Pro" pitchFamily="34" charset="-122"/>
                 <a:cs typeface="Be Vietnam Pro" pitchFamily="34" charset="-120"/>
               </a:rPr>
-              <a:t> giây</a:t>
-            </a:r>
-            <a:r>
-              <a:rPr lang="en-US" sz="2550" dirty="0" spc="-1" kern="0">
+              <a:t> 10. Shopify còn</a:t>
+            </a:r>
+            <a:r>
+              <a:rPr lang="en-US" sz="2550" dirty="0" spc="0" kern="0">
                 <a:solidFill>
                   <a:srgbClr val="14161C"/>
                 </a:solidFill>
@@ -8543,73 +8653,7 @@
                 <a:ea typeface="Be Vietnam Pro" pitchFamily="34" charset="-122"/>
                 <a:cs typeface="Be Vietnam Pro" pitchFamily="34" charset="-120"/>
               </a:rPr>
-              <a:t> mỗi</a:t>
-            </a:r>
-            <a:r>
-              <a:rPr lang="en-US" sz="2550" dirty="0" spc="-20" kern="0">
-                <a:solidFill>
-                  <a:srgbClr val="14161C"/>
-                </a:solidFill>
-                <a:latin typeface="Be Vietnam Pro" pitchFamily="34" charset="0"/>
-                <a:ea typeface="Be Vietnam Pro" pitchFamily="34" charset="-122"/>
-                <a:cs typeface="Be Vietnam Pro" pitchFamily="34" charset="-120"/>
-              </a:rPr>
-              <a:t> yêu</a:t>
-            </a:r>
-            <a:r>
-              <a:rPr lang="en-US" sz="2550" dirty="0" spc="2" kern="0">
-                <a:solidFill>
-                  <a:srgbClr val="14161C"/>
-                </a:solidFill>
-                <a:latin typeface="Be Vietnam Pro" pitchFamily="34" charset="0"/>
-                <a:ea typeface="Be Vietnam Pro" pitchFamily="34" charset="-122"/>
-                <a:cs typeface="Be Vietnam Pro" pitchFamily="34" charset="-120"/>
-              </a:rPr>
-              <a:t> cầu.</a:t>
-            </a:r>
-            <a:r>
-              <a:rPr lang="en-US" sz="2550" dirty="0" spc="-2" kern="0">
-                <a:solidFill>
-                  <a:srgbClr val="14161C"/>
-                </a:solidFill>
-                <a:latin typeface="Be Vietnam Pro" pitchFamily="34" charset="0"/>
-                <a:ea typeface="Be Vietnam Pro" pitchFamily="34" charset="-122"/>
-                <a:cs typeface="Be Vietnam Pro" pitchFamily="34" charset="-120"/>
-              </a:rPr>
-              <a:t> Shopify</a:t>
-            </a:r>
-            <a:r>
-              <a:rPr lang="en-US" sz="2550" dirty="0" spc="0" kern="0">
-                <a:solidFill>
-                  <a:srgbClr val="14161C"/>
-                </a:solidFill>
-                <a:latin typeface="Be Vietnam Pro" pitchFamily="34" charset="0"/>
-                <a:ea typeface="Be Vietnam Pro" pitchFamily="34" charset="-122"/>
-                <a:cs typeface="Be Vietnam Pro" pitchFamily="34" charset="-120"/>
-              </a:rPr>
-              <a:t> còn</a:t>
-            </a:r>
-            <a:r>
-              <a:rPr lang="en-US" sz="2550" dirty="0" spc="1" kern="0">
-                <a:solidFill>
-                  <a:srgbClr val="14161C"/>
-                </a:solidFill>
-                <a:latin typeface="Be Vietnam Pro" pitchFamily="34" charset="0"/>
-                <a:ea typeface="Be Vietnam Pro" pitchFamily="34" charset="-122"/>
-                <a:cs typeface="Be Vietnam Pro" pitchFamily="34" charset="-120"/>
-              </a:rPr>
-              <a:t> mô</a:t>
-            </a:r>
-            <a:r>
-              <a:rPr lang="en-US" sz="2550" dirty="0" spc="0" kern="0">
-                <a:solidFill>
-                  <a:srgbClr val="14161C"/>
-                </a:solidFill>
-                <a:latin typeface="Be Vietnam Pro" pitchFamily="34" charset="0"/>
-                <a:ea typeface="Be Vietnam Pro" pitchFamily="34" charset="-122"/>
-                <a:cs typeface="Be Vietnam Pro" pitchFamily="34" charset="-120"/>
-              </a:rPr>
-              <a:t> phỏng</a:t>
+              <a:t> mô phỏng</a:t>
             </a:r>
             <a:r>
               <a:rPr lang="en-US" sz="2550" dirty="0" spc="13" kern="0">

</xml_diff>

<commit_message>
sd-02-024: deck slide 3 keeps the read and write timeouts apart
Co-Authored-By: Claude Opus 5.5 <noreply@anthropic.com>
Claude-Session: https://claude.ai/code/session_01McBLtMnJbTnB94NeVs8a2V
</commit_message>
<xml_diff>
--- a/system-design-101/vi/lessons/sd-02-024/slides/sd-02-024.pptx
+++ b/system-design-101/vi/lessons/sd-02-024/slides/sd-02-024.pptx
@@ -6769,7 +6769,84 @@
                 <a:ea typeface="Be Vietnam Pro" pitchFamily="34" charset="-122"/>
                 <a:cs typeface="Be Vietnam Pro" pitchFamily="34" charset="-120"/>
               </a:rPr>
-              <a:t>Quá</a:t>
+              <a:t>Đọc</a:t>
+            </a:r>
+            <a:r>
+              <a:rPr lang="en-US" sz="2250" b="1" dirty="0" spc="3" kern="0">
+                <a:solidFill>
+                  <a:srgbClr val="14161C"/>
+                </a:solidFill>
+                <a:latin typeface="Be Vietnam Pro" pitchFamily="34" charset="0"/>
+                <a:ea typeface="Be Vietnam Pro" pitchFamily="34" charset="-122"/>
+                <a:cs typeface="Be Vietnam Pro" pitchFamily="34" charset="-120"/>
+              </a:rPr>
+              <a:t> quá</a:t>
+            </a:r>
+            <a:r>
+              <a:rPr lang="en-US" sz="2250" b="1" dirty="0" spc="1" kern="0">
+                <a:solidFill>
+                  <a:srgbClr val="14161C"/>
+                </a:solidFill>
+                <a:latin typeface="Be Vietnam Pro" pitchFamily="34" charset="0"/>
+                <a:ea typeface="Be Vietnam Pro" pitchFamily="34" charset="-122"/>
+                <a:cs typeface="Be Vietnam Pro" pitchFamily="34" charset="-120"/>
+              </a:rPr>
+              <a:t> 5</a:t>
+            </a:r>
+            <a:r>
+              <a:rPr lang="en-US" sz="2250" b="1" dirty="0" spc="-2" kern="0">
+                <a:solidFill>
+                  <a:srgbClr val="14161C"/>
+                </a:solidFill>
+                <a:latin typeface="Be Vietnam Pro" pitchFamily="34" charset="0"/>
+                <a:ea typeface="Be Vietnam Pro" pitchFamily="34" charset="-122"/>
+                <a:cs typeface="Be Vietnam Pro" pitchFamily="34" charset="-120"/>
+              </a:rPr>
+              <a:t> giây,</a:t>
+            </a:r>
+            <a:r>
+              <a:rPr lang="en-US" sz="2250" b="1" dirty="0" spc="3" kern="0">
+                <a:solidFill>
+                  <a:srgbClr val="14161C"/>
+                </a:solidFill>
+                <a:latin typeface="Be Vietnam Pro" pitchFamily="34" charset="0"/>
+                <a:ea typeface="Be Vietnam Pro" pitchFamily="34" charset="-122"/>
+                <a:cs typeface="Be Vietnam Pro" pitchFamily="34" charset="-120"/>
+              </a:rPr>
+              <a:t> ghi</a:t>
+            </a:r>
+            <a:r>
+              <a:rPr lang="en-US" sz="2250" b="1" dirty="0" spc="2" kern="0">
+                <a:solidFill>
+                  <a:srgbClr val="14161C"/>
+                </a:solidFill>
+                <a:latin typeface="Be Vietnam Pro" pitchFamily="34" charset="0"/>
+                <a:ea typeface="Be Vietnam Pro" pitchFamily="34" charset="-122"/>
+                <a:cs typeface="Be Vietnam Pro" pitchFamily="34" charset="-120"/>
+              </a:rPr>
+              <a:t> quá</a:t>
+            </a:r>
+            <a:r>
+              <a:rPr lang="en-US" sz="2250" b="1" dirty="0" spc="1" kern="0">
+                <a:solidFill>
+                  <a:srgbClr val="14161C"/>
+                </a:solidFill>
+                <a:latin typeface="Be Vietnam Pro" pitchFamily="34" charset="0"/>
+                <a:ea typeface="Be Vietnam Pro" pitchFamily="34" charset="-122"/>
+                <a:cs typeface="Be Vietnam Pro" pitchFamily="34" charset="-120"/>
+              </a:rPr>
+              <a:t> 1</a:t>
+            </a:r>
+            <a:r>
+              <a:rPr lang="en-US" sz="2250" b="1" dirty="0" spc="-2" kern="0">
+                <a:solidFill>
+                  <a:srgbClr val="14161C"/>
+                </a:solidFill>
+                <a:latin typeface="Be Vietnam Pro" pitchFamily="34" charset="0"/>
+                <a:ea typeface="Be Vietnam Pro" pitchFamily="34" charset="-122"/>
+                <a:cs typeface="Be Vietnam Pro" pitchFamily="34" charset="-120"/>
+              </a:rPr>
+              <a:t> giây:</a:t>
             </a:r>
             <a:r>
               <a:rPr lang="en-US" sz="2250" b="1" dirty="0" spc="0" kern="0">
@@ -6780,29 +6857,7 @@
                 <a:ea typeface="Be Vietnam Pro" pitchFamily="34" charset="-122"/>
                 <a:cs typeface="Be Vietnam Pro" pitchFamily="34" charset="-120"/>
               </a:rPr>
-              <a:t> 1</a:t>
-            </a:r>
-            <a:r>
-              <a:rPr lang="en-US" sz="2250" b="1" dirty="0" spc="-1" kern="0">
-                <a:solidFill>
-                  <a:srgbClr val="14161C"/>
-                </a:solidFill>
-                <a:latin typeface="Be Vietnam Pro" pitchFamily="34" charset="0"/>
-                <a:ea typeface="Be Vietnam Pro" pitchFamily="34" charset="-122"/>
-                <a:cs typeface="Be Vietnam Pro" pitchFamily="34" charset="-120"/>
-              </a:rPr>
-              <a:t> giây:</a:t>
-            </a:r>
-            <a:r>
-              <a:rPr lang="en-US" sz="2250" b="1" dirty="0" spc="0" kern="0">
-                <a:solidFill>
-                  <a:srgbClr val="14161C"/>
-                </a:solidFill>
-                <a:latin typeface="Be Vietnam Pro" pitchFamily="34" charset="0"/>
-                <a:ea typeface="Be Vietnam Pro" pitchFamily="34" charset="-122"/>
-                <a:cs typeface="Be Vietnam Pro" pitchFamily="34" charset="-120"/>
-              </a:rPr>
-              <a:t> coi như lỗi</a:t>
+              <a:t> lỗi</a:t>
             </a:r>
             <a:endParaRPr lang="en-US" sz="2250" dirty="0"/>
           </a:p>

</xml_diff>